<commit_message>
Update PowerPoint for song #10 in FUBC - Українські
</commit_message>
<xml_diff>
--- a/fubc-ua/10-Великий Боже! Як на світ погляну.pptx
+++ b/fubc-ua/10-Великий Боже! Як на світ погляну.pptx
@@ -15,9 +15,10 @@
     <p:sldId id="263" r:id="rId9"/>
     <p:sldId id="264" r:id="rId10"/>
     <p:sldId id="265" r:id="rId11"/>
+    <p:sldId id="266" r:id="rId12"/>
   </p:sldIdLst>
   <p:notesMasterIdLst>
-    <p:notesMasterId r:id="rId12"/>
+    <p:notesMasterId r:id="rId13"/>
   </p:notesMasterIdLst>
   <p:sldSz cx="12192000" cy="6858000"/>
   <p:notesSz cx="6858000" cy="12192000"/>
@@ -599,7 +600,7 @@
           <a:p>
             <a:r>
               <a:rPr lang="en-US" dirty="0"/>
-              <a:t/>
+              <a:t>P · 2/2</a:t>
             </a:r>
             <a:endParaRPr lang="en-US" dirty="0"/>
           </a:p>
@@ -623,6 +624,94 @@
             <a:fld id="{F7021451-1387-4CA6-816F-3879F97B5CBC}" type="slidenum">
               <a:rPr lang="en-US"/>
               <a:t>10</a:t>
+            </a:fld>
+            <a:endParaRPr lang="en-US"/>
+          </a:p>
+        </p:txBody>
+      </p:sp>
+    </p:spTree>
+    <p:extLst>
+      <p:ext uri="{BB962C8B-B14F-4D97-AF65-F5344CB8AC3E}">
+        <p14:creationId xmlns:p14="http://schemas.microsoft.com/office/powerpoint/2010/main" val="1024086991"/>
+      </p:ext>
+    </p:extLst>
+  </p:cSld>
+  <p:clrMapOvr>
+    <a:masterClrMapping/>
+  </p:clrMapOvr>
+</p:notes>
+</file>
+
+<file path=ppt/notesSlides/notesSlide11.xml><?xml version="1.0" encoding="utf-8"?>
+<p:notes xmlns:a="http://schemas.openxmlformats.org/drawingml/2006/main" xmlns:r="http://schemas.openxmlformats.org/officeDocument/2006/relationships" xmlns:p="http://schemas.openxmlformats.org/presentationml/2006/main">
+  <p:cSld>
+    <p:spTree>
+      <p:nvGrpSpPr>
+        <p:cNvPr id="1" name=""/>
+        <p:cNvGrpSpPr/>
+        <p:nvPr/>
+      </p:nvGrpSpPr>
+      <p:grpSpPr>
+        <a:xfrm>
+          <a:off x="0" y="0"/>
+          <a:ext cx="0" cy="0"/>
+          <a:chOff x="0" y="0"/>
+          <a:chExt cx="0" cy="0"/>
+        </a:xfrm>
+      </p:grpSpPr>
+      <p:sp>
+        <p:nvSpPr>
+          <p:cNvPr id="2" name="Slide Image Placeholder 1"/>
+          <p:cNvSpPr>
+            <a:spLocks noGrp="1" noRot="1" noChangeAspect="1"/>
+          </p:cNvSpPr>
+          <p:nvPr>
+            <p:ph type="sldImg"/>
+          </p:nvPr>
+        </p:nvSpPr>
+        <p:spPr/>
+      </p:sp>
+      <p:sp>
+        <p:nvSpPr>
+          <p:cNvPr id="3" name="Notes Placeholder 2"/>
+          <p:cNvSpPr>
+            <a:spLocks noGrp="1"/>
+          </p:cNvSpPr>
+          <p:nvPr>
+            <p:ph type="body" idx="1"/>
+          </p:nvPr>
+        </p:nvSpPr>
+        <p:spPr/>
+        <p:txBody>
+          <a:bodyPr/>
+          <a:lstStyle/>
+          <a:p>
+            <a:r>
+              <a:rPr lang="en-US" dirty="0"/>
+              <a:t/>
+            </a:r>
+            <a:endParaRPr lang="en-US" dirty="0"/>
+          </a:p>
+        </p:txBody>
+      </p:sp>
+      <p:sp>
+        <p:nvSpPr>
+          <p:cNvPr id="4" name="Slide Number Placeholder 3"/>
+          <p:cNvSpPr>
+            <a:spLocks noGrp="1"/>
+          </p:cNvSpPr>
+          <p:nvPr>
+            <p:ph type="sldNum" sz="quarter" idx="10"/>
+          </p:nvPr>
+        </p:nvSpPr>
+        <p:spPr/>
+        <p:txBody>
+          <a:bodyPr/>
+          <a:lstStyle/>
+          <a:p>
+            <a:fld id="{F7021451-1387-4CA6-816F-3879F97B5CBC}" type="slidenum">
+              <a:rPr lang="en-US"/>
+              <a:t>11</a:t>
             </a:fld>
             <a:endParaRPr lang="en-US"/>
           </a:p>
@@ -687,7 +776,7 @@
           <a:p>
             <a:r>
               <a:rPr lang="en-US" dirty="0"/>
-              <a:t>P · 1/1</a:t>
+              <a:t>1 · 1/1</a:t>
             </a:r>
             <a:endParaRPr lang="en-US" dirty="0"/>
           </a:p>
@@ -775,7 +864,7 @@
           <a:p>
             <a:r>
               <a:rPr lang="en-US" dirty="0"/>
-              <a:t>1 · 1/1</a:t>
+              <a:t>P · 1/1</a:t>
             </a:r>
             <a:endParaRPr lang="en-US" dirty="0"/>
           </a:p>
@@ -863,7 +952,7 @@
           <a:p>
             <a:r>
               <a:rPr lang="en-US" dirty="0"/>
-              <a:t>P · 1/1</a:t>
+              <a:t>2 · 1/1</a:t>
             </a:r>
             <a:endParaRPr lang="en-US" dirty="0"/>
           </a:p>
@@ -951,7 +1040,7 @@
           <a:p>
             <a:r>
               <a:rPr lang="en-US" dirty="0"/>
-              <a:t>2 · 1/1</a:t>
+              <a:t>P · 1/1</a:t>
             </a:r>
             <a:endParaRPr lang="en-US" dirty="0"/>
           </a:p>
@@ -1039,7 +1128,7 @@
           <a:p>
             <a:r>
               <a:rPr lang="en-US" dirty="0"/>
-              <a:t>P · 1/1</a:t>
+              <a:t>3 · 1/1</a:t>
             </a:r>
             <a:endParaRPr lang="en-US" dirty="0"/>
           </a:p>
@@ -1127,7 +1216,7 @@
           <a:p>
             <a:r>
               <a:rPr lang="en-US" dirty="0"/>
-              <a:t>3 · 1/1</a:t>
+              <a:t>P · 1/1</a:t>
             </a:r>
             <a:endParaRPr lang="en-US" dirty="0"/>
           </a:p>
@@ -1215,7 +1304,7 @@
           <a:p>
             <a:r>
               <a:rPr lang="en-US" dirty="0"/>
-              <a:t>P · 1/2</a:t>
+              <a:t>4 · 1/1</a:t>
             </a:r>
             <a:endParaRPr lang="en-US" dirty="0"/>
           </a:p>
@@ -1303,7 +1392,7 @@
           <a:p>
             <a:r>
               <a:rPr lang="en-US" dirty="0"/>
-              <a:t>P · 2/2</a:t>
+              <a:t>P · 1/2</a:t>
             </a:r>
             <a:endParaRPr lang="en-US" dirty="0"/>
           </a:p>
@@ -1701,68 +1790,34 @@
               <a:buNone/>
             </a:pPr>
             <a:r>
-              <a:rPr lang="en-US" sz="3900" b="1" dirty="0">
-                <a:solidFill>
-                  <a:srgbClr val="FFFFFF"/>
-                </a:solidFill>
-                <a:latin typeface="Arial" pitchFamily="34" charset="0"/>
-                <a:ea typeface="Arial" pitchFamily="34" charset="-122"/>
-                <a:cs typeface="Arial" pitchFamily="34" charset="-120"/>
-              </a:rPr>
-              <a:t>Великий Б‍‍оже! Як на світ погл‍‍яну,</a:t>
-            </a:r>
-            <a:endParaRPr lang="en-US" sz="3900" dirty="0"/>
-          </a:p>
-          <a:p>
-            <a:pPr algn="ctr" indent="0" marL="0">
-              <a:buNone/>
-            </a:pPr>
-            <a:r>
-              <a:rPr lang="en-US" sz="3900" b="1" dirty="0">
-                <a:solidFill>
-                  <a:srgbClr val="FFFFFF"/>
-                </a:solidFill>
-                <a:latin typeface="Arial" pitchFamily="34" charset="0"/>
-                <a:ea typeface="Arial" pitchFamily="34" charset="-122"/>
-                <a:cs typeface="Arial" pitchFamily="34" charset="-120"/>
-              </a:rPr>
-              <a:t>На все, на в‍‍се, Що Т‍‍и створив в кра‍‍сі,</a:t>
-            </a:r>
-            <a:endParaRPr lang="en-US" sz="3900" dirty="0"/>
-          </a:p>
-          <a:p>
-            <a:pPr algn="ctr" indent="0" marL="0">
-              <a:buNone/>
-            </a:pPr>
-            <a:r>
-              <a:rPr lang="en-US" sz="3900" b="1" dirty="0">
-                <a:solidFill>
-                  <a:srgbClr val="FFFFFF"/>
-                </a:solidFill>
-                <a:latin typeface="Arial" pitchFamily="34" charset="0"/>
-                <a:ea typeface="Arial" pitchFamily="34" charset="-122"/>
-                <a:cs typeface="Arial" pitchFamily="34" charset="-120"/>
-              </a:rPr>
-              <a:t>Як кожний тв‍‍ір Тобі складає ш‍‍ану,</a:t>
-            </a:r>
-            <a:endParaRPr lang="en-US" sz="3900" dirty="0"/>
-          </a:p>
-          <a:p>
-            <a:pPr algn="ctr" indent="0" marL="0">
-              <a:buNone/>
-            </a:pPr>
-            <a:r>
-              <a:rPr lang="en-US" sz="3900" b="1" dirty="0">
-                <a:solidFill>
-                  <a:srgbClr val="FFFFFF"/>
-                </a:solidFill>
-                <a:latin typeface="Arial" pitchFamily="34" charset="0"/>
-                <a:ea typeface="Arial" pitchFamily="34" charset="-122"/>
-                <a:cs typeface="Arial" pitchFamily="34" charset="-120"/>
-              </a:rPr>
-              <a:t>І як обн‍‍яв люб‍‍ов'ю Ти ус‍‍іх;</a:t>
-            </a:r>
-            <a:endParaRPr lang="en-US" sz="3900" dirty="0"/>
+              <a:rPr lang="en-US" sz="5100" b="1" dirty="0">
+                <a:solidFill>
+                  <a:srgbClr val="FFFFFF"/>
+                </a:solidFill>
+                <a:latin typeface="Arial" pitchFamily="34" charset="0"/>
+                <a:ea typeface="Arial" pitchFamily="34" charset="-122"/>
+                <a:cs typeface="Arial" pitchFamily="34" charset="-120"/>
+              </a:rPr>
+              <a:t>Великий Б‍‍оже! </a:t>
+            </a:r>
+            <a:endParaRPr lang="en-US" sz="5100" dirty="0"/>
+          </a:p>
+          <a:p>
+            <a:pPr algn="ctr" indent="0" marL="0">
+              <a:buNone/>
+            </a:pPr>
+            <a:r>
+              <a:rPr lang="en-US" sz="5100" b="1" dirty="0">
+                <a:solidFill>
+                  <a:srgbClr val="FFFFFF"/>
+                </a:solidFill>
+                <a:latin typeface="Arial" pitchFamily="34" charset="0"/>
+                <a:ea typeface="Arial" pitchFamily="34" charset="-122"/>
+                <a:cs typeface="Arial" pitchFamily="34" charset="-120"/>
+              </a:rPr>
+              <a:t>Як на світ погл‍‍яну</a:t>
+            </a:r>
+            <a:endParaRPr lang="en-US" sz="5100" dirty="0"/>
           </a:p>
         </p:txBody>
       </p:sp>
@@ -1777,6 +1832,139 @@
 <file path=ppt/slides/slide10.xml><?xml version="1.0" encoding="utf-8"?>
 <p:sld xmlns:a="http://schemas.openxmlformats.org/drawingml/2006/main" xmlns:r="http://schemas.openxmlformats.org/officeDocument/2006/relationships" xmlns:p="http://schemas.openxmlformats.org/presentationml/2006/main">
   <p:cSld name="Slide 10">
+    <p:bg>
+      <p:bgPr>
+        <a:solidFill>
+          <a:srgbClr val="000000"/>
+        </a:solidFill>
+      </p:bgPr>
+    </p:bg>
+    <p:spTree>
+      <p:nvGrpSpPr>
+        <p:cNvPr id="1" name=""/>
+        <p:cNvGrpSpPr/>
+        <p:nvPr/>
+      </p:nvGrpSpPr>
+      <p:grpSpPr>
+        <a:xfrm>
+          <a:off x="0" y="0"/>
+          <a:ext cx="0" cy="0"/>
+          <a:chOff x="0" y="0"/>
+          <a:chExt cx="0" cy="0"/>
+        </a:xfrm>
+      </p:grpSpPr>
+      <p:sp>
+        <p:nvSpPr>
+          <p:cNvPr id="2" name="Text 0"/>
+          <p:cNvSpPr txBox="1"/>
+          <p:nvPr/>
+        </p:nvSpPr>
+        <p:spPr>
+          <a:xfrm>
+            <a:off x="292608" y="457200"/>
+            <a:ext cx="11612880" cy="5943600"/>
+          </a:xfrm>
+          <a:prstGeom prst="rect">
+            <a:avLst/>
+          </a:prstGeom>
+          <a:noFill/>
+          <a:ln/>
+        </p:spPr>
+        <p:txBody>
+          <a:bodyPr wrap="square" lIns="0" tIns="0" rIns="0" bIns="0" rtlCol="0" anchor="ctr"/>
+          <a:lstStyle/>
+          <a:p>
+            <a:pPr algn="ctr" indent="0" marL="0">
+              <a:buNone/>
+            </a:pPr>
+            <a:r>
+              <a:rPr lang="en-US" sz="5100" b="1" i="1" dirty="0">
+                <a:solidFill>
+                  <a:srgbClr val="FFFFFF"/>
+                </a:solidFill>
+                <a:latin typeface="Arial" pitchFamily="34" charset="0"/>
+                <a:ea typeface="Arial" pitchFamily="34" charset="-122"/>
+                <a:cs typeface="Arial" pitchFamily="34" charset="-120"/>
+              </a:rPr>
+              <a:t>Великий Ти! Вел‍‍икий Т‍‍и!</a:t>
+            </a:r>
+            <a:endParaRPr lang="en-US" sz="5100" dirty="0"/>
+          </a:p>
+          <a:p>
+            <a:pPr algn="ctr" indent="0" marL="0">
+              <a:buNone/>
+            </a:pPr>
+            <a:endParaRPr lang="en-US" sz="5100" dirty="0"/>
+          </a:p>
+          <a:p>
+            <a:pPr algn="ctr" indent="0" marL="0">
+              <a:buNone/>
+            </a:pPr>
+            <a:r>
+              <a:rPr lang="en-US" sz="5100" b="1" i="1" dirty="0">
+                <a:solidFill>
+                  <a:srgbClr val="FFFFFF"/>
+                </a:solidFill>
+                <a:latin typeface="Arial" pitchFamily="34" charset="0"/>
+                <a:ea typeface="Arial" pitchFamily="34" charset="-122"/>
+                <a:cs typeface="Arial" pitchFamily="34" charset="-120"/>
+              </a:rPr>
+              <a:t>***</a:t>
+            </a:r>
+            <a:endParaRPr lang="en-US" sz="5100" dirty="0"/>
+          </a:p>
+        </p:txBody>
+      </p:sp>
+      <p:sp>
+        <p:nvSpPr>
+          <p:cNvPr id="3" name="Text 1"/>
+          <p:cNvSpPr txBox="1"/>
+          <p:nvPr/>
+        </p:nvSpPr>
+        <p:spPr>
+          <a:xfrm>
+            <a:off x="9235440" y="6126480"/>
+            <a:ext cx="2743200" cy="548640"/>
+          </a:xfrm>
+          <a:prstGeom prst="rect">
+            <a:avLst/>
+          </a:prstGeom>
+          <a:noFill/>
+          <a:ln/>
+        </p:spPr>
+        <p:txBody>
+          <a:bodyPr wrap="square" lIns="0" tIns="0" rIns="0" bIns="0" rtlCol="0" anchor="ctr"/>
+          <a:lstStyle/>
+          <a:p>
+            <a:pPr algn="r" indent="0" marL="0">
+              <a:buNone/>
+            </a:pPr>
+            <a:r>
+              <a:rPr lang="en-US" sz="2400" dirty="0">
+                <a:solidFill>
+                  <a:srgbClr val="8A8A8A"/>
+                </a:solidFill>
+                <a:latin typeface="Arial" pitchFamily="34" charset="0"/>
+                <a:ea typeface="Arial" pitchFamily="34" charset="-122"/>
+                <a:cs typeface="Arial" pitchFamily="34" charset="-120"/>
+              </a:rPr>
+              <a:t>○ ●</a:t>
+            </a:r>
+            <a:endParaRPr lang="en-US" sz="2400" dirty="0"/>
+          </a:p>
+        </p:txBody>
+      </p:sp>
+    </p:spTree>
+  </p:cSld>
+  <p:clrMapOvr>
+    <a:masterClrMapping/>
+  </p:clrMapOvr>
+</p:sld>
+</file>
+
+<file path=ppt/slides/slide11.xml><?xml version="1.0" encoding="utf-8"?>
+<p:sld xmlns:a="http://schemas.openxmlformats.org/drawingml/2006/main" xmlns:r="http://schemas.openxmlformats.org/officeDocument/2006/relationships" xmlns:p="http://schemas.openxmlformats.org/presentationml/2006/main">
+  <p:cSld name="Slide 11">
     <p:bg>
       <p:bgPr>
         <a:solidFill>
@@ -1855,68 +2043,68 @@
               <a:buNone/>
             </a:pPr>
             <a:r>
-              <a:rPr lang="en-US" sz="4400" b="1" i="1" dirty="0">
-                <a:solidFill>
-                  <a:srgbClr val="FFFFFF"/>
-                </a:solidFill>
-                <a:latin typeface="Arial" pitchFamily="34" charset="0"/>
-                <a:ea typeface="Arial" pitchFamily="34" charset="-122"/>
-                <a:cs typeface="Arial" pitchFamily="34" charset="-120"/>
-              </a:rPr>
-              <a:t>Тоді, Госп‍‍одь, мій д‍‍ух співа То‍‍бі:</a:t>
-            </a:r>
-            <a:endParaRPr lang="en-US" sz="4400" dirty="0"/>
-          </a:p>
-          <a:p>
-            <a:pPr algn="ctr" indent="0" marL="0">
-              <a:buNone/>
-            </a:pPr>
-            <a:r>
-              <a:rPr lang="en-US" sz="4400" b="1" i="1" dirty="0">
-                <a:solidFill>
-                  <a:srgbClr val="FFFFFF"/>
-                </a:solidFill>
-                <a:latin typeface="Arial" pitchFamily="34" charset="0"/>
-                <a:ea typeface="Arial" pitchFamily="34" charset="-122"/>
-                <a:cs typeface="Arial" pitchFamily="34" charset="-120"/>
-              </a:rPr>
-              <a:t>Великий Т‍‍и! Великий Т‍‍и!</a:t>
-            </a:r>
-            <a:endParaRPr lang="en-US" sz="4400" dirty="0"/>
-          </a:p>
-          <a:p>
-            <a:pPr algn="ctr" indent="0" marL="0">
-              <a:buNone/>
-            </a:pPr>
-            <a:r>
-              <a:rPr lang="en-US" sz="4400" b="1" i="1" dirty="0">
-                <a:solidFill>
-                  <a:srgbClr val="FFFFFF"/>
-                </a:solidFill>
-                <a:latin typeface="Arial" pitchFamily="34" charset="0"/>
-                <a:ea typeface="Arial" pitchFamily="34" charset="-122"/>
-                <a:cs typeface="Arial" pitchFamily="34" charset="-120"/>
-              </a:rPr>
-              <a:t>Тоді, Госп‍‍одь, мій д‍‍ух співа То‍‍бі:</a:t>
-            </a:r>
-            <a:endParaRPr lang="en-US" sz="4400" dirty="0"/>
-          </a:p>
-          <a:p>
-            <a:pPr algn="ctr" indent="0" marL="0">
-              <a:buNone/>
-            </a:pPr>
-            <a:r>
-              <a:rPr lang="en-US" sz="4400" b="1" i="1" dirty="0">
-                <a:solidFill>
-                  <a:srgbClr val="FFFFFF"/>
-                </a:solidFill>
-                <a:latin typeface="Arial" pitchFamily="34" charset="0"/>
-                <a:ea typeface="Arial" pitchFamily="34" charset="-122"/>
-                <a:cs typeface="Arial" pitchFamily="34" charset="-120"/>
-              </a:rPr>
-              <a:t>Великий Ти! Вел‍‍икий Т‍‍и!</a:t>
-            </a:r>
-            <a:endParaRPr lang="en-US" sz="4400" dirty="0"/>
+              <a:rPr lang="en-US" sz="5100" b="1" dirty="0">
+                <a:solidFill>
+                  <a:srgbClr val="FFFFFF"/>
+                </a:solidFill>
+                <a:latin typeface="Arial" pitchFamily="34" charset="0"/>
+                <a:ea typeface="Arial" pitchFamily="34" charset="-122"/>
+                <a:cs typeface="Arial" pitchFamily="34" charset="-120"/>
+              </a:rPr>
+              <a:t>Великий Б‍‍оже! Як на світ погл‍‍яну,</a:t>
+            </a:r>
+            <a:endParaRPr lang="en-US" sz="5100" dirty="0"/>
+          </a:p>
+          <a:p>
+            <a:pPr algn="ctr" indent="0" marL="0">
+              <a:buNone/>
+            </a:pPr>
+            <a:r>
+              <a:rPr lang="en-US" sz="5100" b="1" dirty="0">
+                <a:solidFill>
+                  <a:srgbClr val="FFFFFF"/>
+                </a:solidFill>
+                <a:latin typeface="Arial" pitchFamily="34" charset="0"/>
+                <a:ea typeface="Arial" pitchFamily="34" charset="-122"/>
+                <a:cs typeface="Arial" pitchFamily="34" charset="-120"/>
+              </a:rPr>
+              <a:t>На все, на в‍‍се, Що Т‍‍и створив в кра‍‍сі,</a:t>
+            </a:r>
+            <a:endParaRPr lang="en-US" sz="5100" dirty="0"/>
+          </a:p>
+          <a:p>
+            <a:pPr algn="ctr" indent="0" marL="0">
+              <a:buNone/>
+            </a:pPr>
+            <a:r>
+              <a:rPr lang="en-US" sz="5100" b="1" dirty="0">
+                <a:solidFill>
+                  <a:srgbClr val="FFFFFF"/>
+                </a:solidFill>
+                <a:latin typeface="Arial" pitchFamily="34" charset="0"/>
+                <a:ea typeface="Arial" pitchFamily="34" charset="-122"/>
+                <a:cs typeface="Arial" pitchFamily="34" charset="-120"/>
+              </a:rPr>
+              <a:t>Як кожний тв‍‍ір Тобі складає ш‍‍ану,</a:t>
+            </a:r>
+            <a:endParaRPr lang="en-US" sz="5100" dirty="0"/>
+          </a:p>
+          <a:p>
+            <a:pPr algn="ctr" indent="0" marL="0">
+              <a:buNone/>
+            </a:pPr>
+            <a:r>
+              <a:rPr lang="en-US" sz="5100" b="1" dirty="0">
+                <a:solidFill>
+                  <a:srgbClr val="FFFFFF"/>
+                </a:solidFill>
+                <a:latin typeface="Arial" pitchFamily="34" charset="0"/>
+                <a:ea typeface="Arial" pitchFamily="34" charset="-122"/>
+                <a:cs typeface="Arial" pitchFamily="34" charset="-120"/>
+              </a:rPr>
+              <a:t>І як обн‍‍яв люб‍‍ов'ю Ти ус‍‍іх;</a:t>
+            </a:r>
+            <a:endParaRPr lang="en-US" sz="5100" dirty="0"/>
           </a:p>
         </p:txBody>
       </p:sp>
@@ -1977,68 +2165,68 @@
               <a:buNone/>
             </a:pPr>
             <a:r>
-              <a:rPr lang="en-US" sz="5000" b="1" dirty="0">
-                <a:solidFill>
-                  <a:srgbClr val="FFFFFF"/>
-                </a:solidFill>
-                <a:latin typeface="Arial" pitchFamily="34" charset="0"/>
-                <a:ea typeface="Arial" pitchFamily="34" charset="-122"/>
-                <a:cs typeface="Arial" pitchFamily="34" charset="-120"/>
-              </a:rPr>
-              <a:t>Коли дивлюсь на мерехтливі зорі,</a:t>
-            </a:r>
-            <a:endParaRPr lang="en-US" sz="5000" dirty="0"/>
-          </a:p>
-          <a:p>
-            <a:pPr algn="ctr" indent="0" marL="0">
-              <a:buNone/>
-            </a:pPr>
-            <a:r>
-              <a:rPr lang="en-US" sz="5000" b="1" dirty="0">
-                <a:solidFill>
-                  <a:srgbClr val="FFFFFF"/>
-                </a:solidFill>
-                <a:latin typeface="Arial" pitchFamily="34" charset="0"/>
-                <a:ea typeface="Arial" pitchFamily="34" charset="-122"/>
-                <a:cs typeface="Arial" pitchFamily="34" charset="-120"/>
-              </a:rPr>
-              <a:t>Там, де незнані нам горять світи,</a:t>
-            </a:r>
-            <a:endParaRPr lang="en-US" sz="5000" dirty="0"/>
-          </a:p>
-          <a:p>
-            <a:pPr algn="ctr" indent="0" marL="0">
-              <a:buNone/>
-            </a:pPr>
-            <a:r>
-              <a:rPr lang="en-US" sz="5000" b="1" dirty="0">
-                <a:solidFill>
-                  <a:srgbClr val="FFFFFF"/>
-                </a:solidFill>
-                <a:latin typeface="Arial" pitchFamily="34" charset="0"/>
-                <a:ea typeface="Arial" pitchFamily="34" charset="-122"/>
-                <a:cs typeface="Arial" pitchFamily="34" charset="-120"/>
-              </a:rPr>
-              <a:t>Де сонце й місяць у небес просторі</a:t>
-            </a:r>
-            <a:endParaRPr lang="en-US" sz="5000" dirty="0"/>
-          </a:p>
-          <a:p>
-            <a:pPr algn="ctr" indent="0" marL="0">
-              <a:buNone/>
-            </a:pPr>
-            <a:r>
-              <a:rPr lang="en-US" sz="5000" b="1" dirty="0">
-                <a:solidFill>
-                  <a:srgbClr val="FFFFFF"/>
-                </a:solidFill>
-                <a:latin typeface="Arial" pitchFamily="34" charset="0"/>
-                <a:ea typeface="Arial" pitchFamily="34" charset="-122"/>
-                <a:cs typeface="Arial" pitchFamily="34" charset="-120"/>
-              </a:rPr>
-              <a:t>Пливуть у тиші, наче кораблі;</a:t>
-            </a:r>
-            <a:endParaRPr lang="en-US" sz="5000" dirty="0"/>
+              <a:rPr lang="en-US" sz="5100" b="1" i="1" dirty="0">
+                <a:solidFill>
+                  <a:srgbClr val="FFFFFF"/>
+                </a:solidFill>
+                <a:latin typeface="Arial" pitchFamily="34" charset="0"/>
+                <a:ea typeface="Arial" pitchFamily="34" charset="-122"/>
+                <a:cs typeface="Arial" pitchFamily="34" charset="-120"/>
+              </a:rPr>
+              <a:t>Тоді, Госп‍‍одь, мій д‍‍ух співа То‍‍бі:</a:t>
+            </a:r>
+            <a:endParaRPr lang="en-US" sz="5100" dirty="0"/>
+          </a:p>
+          <a:p>
+            <a:pPr algn="ctr" indent="0" marL="0">
+              <a:buNone/>
+            </a:pPr>
+            <a:r>
+              <a:rPr lang="en-US" sz="5100" b="1" i="1" dirty="0">
+                <a:solidFill>
+                  <a:srgbClr val="FFFFFF"/>
+                </a:solidFill>
+                <a:latin typeface="Arial" pitchFamily="34" charset="0"/>
+                <a:ea typeface="Arial" pitchFamily="34" charset="-122"/>
+                <a:cs typeface="Arial" pitchFamily="34" charset="-120"/>
+              </a:rPr>
+              <a:t>Великий Т‍‍и! Великий Т‍‍и!</a:t>
+            </a:r>
+            <a:endParaRPr lang="en-US" sz="5100" dirty="0"/>
+          </a:p>
+          <a:p>
+            <a:pPr algn="ctr" indent="0" marL="0">
+              <a:buNone/>
+            </a:pPr>
+            <a:r>
+              <a:rPr lang="en-US" sz="5100" b="1" i="1" dirty="0">
+                <a:solidFill>
+                  <a:srgbClr val="FFFFFF"/>
+                </a:solidFill>
+                <a:latin typeface="Arial" pitchFamily="34" charset="0"/>
+                <a:ea typeface="Arial" pitchFamily="34" charset="-122"/>
+                <a:cs typeface="Arial" pitchFamily="34" charset="-120"/>
+              </a:rPr>
+              <a:t>Тоді, Госп‍‍одь, мій д‍‍ух співа То‍‍бі:</a:t>
+            </a:r>
+            <a:endParaRPr lang="en-US" sz="5100" dirty="0"/>
+          </a:p>
+          <a:p>
+            <a:pPr algn="ctr" indent="0" marL="0">
+              <a:buNone/>
+            </a:pPr>
+            <a:r>
+              <a:rPr lang="en-US" sz="5100" b="1" i="1" dirty="0">
+                <a:solidFill>
+                  <a:srgbClr val="FFFFFF"/>
+                </a:solidFill>
+                <a:latin typeface="Arial" pitchFamily="34" charset="0"/>
+                <a:ea typeface="Arial" pitchFamily="34" charset="-122"/>
+                <a:cs typeface="Arial" pitchFamily="34" charset="-120"/>
+              </a:rPr>
+              <a:t>Великий Ти! Вел‍‍икий Т‍‍и!</a:t>
+            </a:r>
+            <a:endParaRPr lang="en-US" sz="5100" dirty="0"/>
           </a:p>
         </p:txBody>
       </p:sp>
@@ -2099,68 +2287,68 @@
               <a:buNone/>
             </a:pPr>
             <a:r>
-              <a:rPr lang="en-US" sz="4400" b="1" i="1" dirty="0">
-                <a:solidFill>
-                  <a:srgbClr val="FFFFFF"/>
-                </a:solidFill>
-                <a:latin typeface="Arial" pitchFamily="34" charset="0"/>
-                <a:ea typeface="Arial" pitchFamily="34" charset="-122"/>
-                <a:cs typeface="Arial" pitchFamily="34" charset="-120"/>
-              </a:rPr>
-              <a:t>Тоді, Госп‍‍одь, мій д‍‍ух співа То‍‍бі:</a:t>
-            </a:r>
-            <a:endParaRPr lang="en-US" sz="4400" dirty="0"/>
-          </a:p>
-          <a:p>
-            <a:pPr algn="ctr" indent="0" marL="0">
-              <a:buNone/>
-            </a:pPr>
-            <a:r>
-              <a:rPr lang="en-US" sz="4400" b="1" i="1" dirty="0">
-                <a:solidFill>
-                  <a:srgbClr val="FFFFFF"/>
-                </a:solidFill>
-                <a:latin typeface="Arial" pitchFamily="34" charset="0"/>
-                <a:ea typeface="Arial" pitchFamily="34" charset="-122"/>
-                <a:cs typeface="Arial" pitchFamily="34" charset="-120"/>
-              </a:rPr>
-              <a:t>Великий Т‍‍и! Великий Т‍‍и!</a:t>
-            </a:r>
-            <a:endParaRPr lang="en-US" sz="4400" dirty="0"/>
-          </a:p>
-          <a:p>
-            <a:pPr algn="ctr" indent="0" marL="0">
-              <a:buNone/>
-            </a:pPr>
-            <a:r>
-              <a:rPr lang="en-US" sz="4400" b="1" i="1" dirty="0">
-                <a:solidFill>
-                  <a:srgbClr val="FFFFFF"/>
-                </a:solidFill>
-                <a:latin typeface="Arial" pitchFamily="34" charset="0"/>
-                <a:ea typeface="Arial" pitchFamily="34" charset="-122"/>
-                <a:cs typeface="Arial" pitchFamily="34" charset="-120"/>
-              </a:rPr>
-              <a:t>Тоді, Госп‍‍одь, мій д‍‍ух співа То‍‍бі:</a:t>
-            </a:r>
-            <a:endParaRPr lang="en-US" sz="4400" dirty="0"/>
-          </a:p>
-          <a:p>
-            <a:pPr algn="ctr" indent="0" marL="0">
-              <a:buNone/>
-            </a:pPr>
-            <a:r>
-              <a:rPr lang="en-US" sz="4400" b="1" i="1" dirty="0">
-                <a:solidFill>
-                  <a:srgbClr val="FFFFFF"/>
-                </a:solidFill>
-                <a:latin typeface="Arial" pitchFamily="34" charset="0"/>
-                <a:ea typeface="Arial" pitchFamily="34" charset="-122"/>
-                <a:cs typeface="Arial" pitchFamily="34" charset="-120"/>
-              </a:rPr>
-              <a:t>Великий Ти! Вел‍‍икий Т‍‍и!</a:t>
-            </a:r>
-            <a:endParaRPr lang="en-US" sz="4400" dirty="0"/>
+              <a:rPr lang="en-US" sz="5100" b="1" dirty="0">
+                <a:solidFill>
+                  <a:srgbClr val="FFFFFF"/>
+                </a:solidFill>
+                <a:latin typeface="Arial" pitchFamily="34" charset="0"/>
+                <a:ea typeface="Arial" pitchFamily="34" charset="-122"/>
+                <a:cs typeface="Arial" pitchFamily="34" charset="-120"/>
+              </a:rPr>
+              <a:t>Коли дивлюсь на мерехтливі зорі,</a:t>
+            </a:r>
+            <a:endParaRPr lang="en-US" sz="5100" dirty="0"/>
+          </a:p>
+          <a:p>
+            <a:pPr algn="ctr" indent="0" marL="0">
+              <a:buNone/>
+            </a:pPr>
+            <a:r>
+              <a:rPr lang="en-US" sz="5100" b="1" dirty="0">
+                <a:solidFill>
+                  <a:srgbClr val="FFFFFF"/>
+                </a:solidFill>
+                <a:latin typeface="Arial" pitchFamily="34" charset="0"/>
+                <a:ea typeface="Arial" pitchFamily="34" charset="-122"/>
+                <a:cs typeface="Arial" pitchFamily="34" charset="-120"/>
+              </a:rPr>
+              <a:t>Там, де незнані нам горять світи,</a:t>
+            </a:r>
+            <a:endParaRPr lang="en-US" sz="5100" dirty="0"/>
+          </a:p>
+          <a:p>
+            <a:pPr algn="ctr" indent="0" marL="0">
+              <a:buNone/>
+            </a:pPr>
+            <a:r>
+              <a:rPr lang="en-US" sz="5100" b="1" dirty="0">
+                <a:solidFill>
+                  <a:srgbClr val="FFFFFF"/>
+                </a:solidFill>
+                <a:latin typeface="Arial" pitchFamily="34" charset="0"/>
+                <a:ea typeface="Arial" pitchFamily="34" charset="-122"/>
+                <a:cs typeface="Arial" pitchFamily="34" charset="-120"/>
+              </a:rPr>
+              <a:t>Де сонце й місяць у небес просторі</a:t>
+            </a:r>
+            <a:endParaRPr lang="en-US" sz="5100" dirty="0"/>
+          </a:p>
+          <a:p>
+            <a:pPr algn="ctr" indent="0" marL="0">
+              <a:buNone/>
+            </a:pPr>
+            <a:r>
+              <a:rPr lang="en-US" sz="5100" b="1" dirty="0">
+                <a:solidFill>
+                  <a:srgbClr val="FFFFFF"/>
+                </a:solidFill>
+                <a:latin typeface="Arial" pitchFamily="34" charset="0"/>
+                <a:ea typeface="Arial" pitchFamily="34" charset="-122"/>
+                <a:cs typeface="Arial" pitchFamily="34" charset="-120"/>
+              </a:rPr>
+              <a:t>Пливуть у тиші, наче кораблі;</a:t>
+            </a:r>
+            <a:endParaRPr lang="en-US" sz="5100" dirty="0"/>
           </a:p>
         </p:txBody>
       </p:sp>
@@ -2221,68 +2409,68 @@
               <a:buNone/>
             </a:pPr>
             <a:r>
-              <a:rPr lang="en-US" sz="5000" b="1" dirty="0">
-                <a:solidFill>
-                  <a:srgbClr val="FFFFFF"/>
-                </a:solidFill>
-                <a:latin typeface="Arial" pitchFamily="34" charset="0"/>
-                <a:ea typeface="Arial" pitchFamily="34" charset="-122"/>
-                <a:cs typeface="Arial" pitchFamily="34" charset="-120"/>
-              </a:rPr>
-              <a:t>Коли беру я книгу Заповітів</a:t>
-            </a:r>
-            <a:endParaRPr lang="en-US" sz="5000" dirty="0"/>
-          </a:p>
-          <a:p>
-            <a:pPr algn="ctr" indent="0" marL="0">
-              <a:buNone/>
-            </a:pPr>
-            <a:r>
-              <a:rPr lang="en-US" sz="5000" b="1" dirty="0">
-                <a:solidFill>
-                  <a:srgbClr val="FFFFFF"/>
-                </a:solidFill>
-                <a:latin typeface="Arial" pitchFamily="34" charset="0"/>
-                <a:ea typeface="Arial" pitchFamily="34" charset="-122"/>
-                <a:cs typeface="Arial" pitchFamily="34" charset="-120"/>
-              </a:rPr>
-              <a:t>І в Ній читаю про Твої діла,</a:t>
-            </a:r>
-            <a:endParaRPr lang="en-US" sz="5000" dirty="0"/>
-          </a:p>
-          <a:p>
-            <a:pPr algn="ctr" indent="0" marL="0">
-              <a:buNone/>
-            </a:pPr>
-            <a:r>
-              <a:rPr lang="en-US" sz="5000" b="1" dirty="0">
-                <a:solidFill>
-                  <a:srgbClr val="FFFFFF"/>
-                </a:solidFill>
-                <a:latin typeface="Arial" pitchFamily="34" charset="0"/>
-                <a:ea typeface="Arial" pitchFamily="34" charset="-122"/>
-                <a:cs typeface="Arial" pitchFamily="34" charset="-120"/>
-              </a:rPr>
-              <a:t>Як полюбив Ти нас, людей на світі,</a:t>
-            </a:r>
-            <a:endParaRPr lang="en-US" sz="5000" dirty="0"/>
-          </a:p>
-          <a:p>
-            <a:pPr algn="ctr" indent="0" marL="0">
-              <a:buNone/>
-            </a:pPr>
-            <a:r>
-              <a:rPr lang="en-US" sz="5000" b="1" dirty="0">
-                <a:solidFill>
-                  <a:srgbClr val="FFFFFF"/>
-                </a:solidFill>
-                <a:latin typeface="Arial" pitchFamily="34" charset="0"/>
-                <a:ea typeface="Arial" pitchFamily="34" charset="-122"/>
-                <a:cs typeface="Arial" pitchFamily="34" charset="-120"/>
-              </a:rPr>
-              <a:t>І Свого Сина з неба нам послав;</a:t>
-            </a:r>
-            <a:endParaRPr lang="en-US" sz="5000" dirty="0"/>
+              <a:rPr lang="en-US" sz="5100" b="1" i="1" dirty="0">
+                <a:solidFill>
+                  <a:srgbClr val="FFFFFF"/>
+                </a:solidFill>
+                <a:latin typeface="Arial" pitchFamily="34" charset="0"/>
+                <a:ea typeface="Arial" pitchFamily="34" charset="-122"/>
+                <a:cs typeface="Arial" pitchFamily="34" charset="-120"/>
+              </a:rPr>
+              <a:t>Тоді, Госп‍‍одь, мій д‍‍ух співа То‍‍бі:</a:t>
+            </a:r>
+            <a:endParaRPr lang="en-US" sz="5100" dirty="0"/>
+          </a:p>
+          <a:p>
+            <a:pPr algn="ctr" indent="0" marL="0">
+              <a:buNone/>
+            </a:pPr>
+            <a:r>
+              <a:rPr lang="en-US" sz="5100" b="1" i="1" dirty="0">
+                <a:solidFill>
+                  <a:srgbClr val="FFFFFF"/>
+                </a:solidFill>
+                <a:latin typeface="Arial" pitchFamily="34" charset="0"/>
+                <a:ea typeface="Arial" pitchFamily="34" charset="-122"/>
+                <a:cs typeface="Arial" pitchFamily="34" charset="-120"/>
+              </a:rPr>
+              <a:t>Великий Т‍‍и! Великий Т‍‍и!</a:t>
+            </a:r>
+            <a:endParaRPr lang="en-US" sz="5100" dirty="0"/>
+          </a:p>
+          <a:p>
+            <a:pPr algn="ctr" indent="0" marL="0">
+              <a:buNone/>
+            </a:pPr>
+            <a:r>
+              <a:rPr lang="en-US" sz="5100" b="1" i="1" dirty="0">
+                <a:solidFill>
+                  <a:srgbClr val="FFFFFF"/>
+                </a:solidFill>
+                <a:latin typeface="Arial" pitchFamily="34" charset="0"/>
+                <a:ea typeface="Arial" pitchFamily="34" charset="-122"/>
+                <a:cs typeface="Arial" pitchFamily="34" charset="-120"/>
+              </a:rPr>
+              <a:t>Тоді, Госп‍‍одь, мій д‍‍ух співа То‍‍бі:</a:t>
+            </a:r>
+            <a:endParaRPr lang="en-US" sz="5100" dirty="0"/>
+          </a:p>
+          <a:p>
+            <a:pPr algn="ctr" indent="0" marL="0">
+              <a:buNone/>
+            </a:pPr>
+            <a:r>
+              <a:rPr lang="en-US" sz="5100" b="1" i="1" dirty="0">
+                <a:solidFill>
+                  <a:srgbClr val="FFFFFF"/>
+                </a:solidFill>
+                <a:latin typeface="Arial" pitchFamily="34" charset="0"/>
+                <a:ea typeface="Arial" pitchFamily="34" charset="-122"/>
+                <a:cs typeface="Arial" pitchFamily="34" charset="-120"/>
+              </a:rPr>
+              <a:t>Великий Ти! Вел‍‍икий Т‍‍и!</a:t>
+            </a:r>
+            <a:endParaRPr lang="en-US" sz="5100" dirty="0"/>
           </a:p>
         </p:txBody>
       </p:sp>
@@ -2343,68 +2531,68 @@
               <a:buNone/>
             </a:pPr>
             <a:r>
-              <a:rPr lang="en-US" sz="4400" b="1" i="1" dirty="0">
-                <a:solidFill>
-                  <a:srgbClr val="FFFFFF"/>
-                </a:solidFill>
-                <a:latin typeface="Arial" pitchFamily="34" charset="0"/>
-                <a:ea typeface="Arial" pitchFamily="34" charset="-122"/>
-                <a:cs typeface="Arial" pitchFamily="34" charset="-120"/>
-              </a:rPr>
-              <a:t>Тоді, Госп‍‍одь, мій д‍‍ух співа То‍‍бі:</a:t>
-            </a:r>
-            <a:endParaRPr lang="en-US" sz="4400" dirty="0"/>
-          </a:p>
-          <a:p>
-            <a:pPr algn="ctr" indent="0" marL="0">
-              <a:buNone/>
-            </a:pPr>
-            <a:r>
-              <a:rPr lang="en-US" sz="4400" b="1" i="1" dirty="0">
-                <a:solidFill>
-                  <a:srgbClr val="FFFFFF"/>
-                </a:solidFill>
-                <a:latin typeface="Arial" pitchFamily="34" charset="0"/>
-                <a:ea typeface="Arial" pitchFamily="34" charset="-122"/>
-                <a:cs typeface="Arial" pitchFamily="34" charset="-120"/>
-              </a:rPr>
-              <a:t>Великий Т‍‍и! Великий Т‍‍и!</a:t>
-            </a:r>
-            <a:endParaRPr lang="en-US" sz="4400" dirty="0"/>
-          </a:p>
-          <a:p>
-            <a:pPr algn="ctr" indent="0" marL="0">
-              <a:buNone/>
-            </a:pPr>
-            <a:r>
-              <a:rPr lang="en-US" sz="4400" b="1" i="1" dirty="0">
-                <a:solidFill>
-                  <a:srgbClr val="FFFFFF"/>
-                </a:solidFill>
-                <a:latin typeface="Arial" pitchFamily="34" charset="0"/>
-                <a:ea typeface="Arial" pitchFamily="34" charset="-122"/>
-                <a:cs typeface="Arial" pitchFamily="34" charset="-120"/>
-              </a:rPr>
-              <a:t>Тоді, Госп‍‍одь, мій д‍‍ух співа То‍‍бі:</a:t>
-            </a:r>
-            <a:endParaRPr lang="en-US" sz="4400" dirty="0"/>
-          </a:p>
-          <a:p>
-            <a:pPr algn="ctr" indent="0" marL="0">
-              <a:buNone/>
-            </a:pPr>
-            <a:r>
-              <a:rPr lang="en-US" sz="4400" b="1" i="1" dirty="0">
-                <a:solidFill>
-                  <a:srgbClr val="FFFFFF"/>
-                </a:solidFill>
-                <a:latin typeface="Arial" pitchFamily="34" charset="0"/>
-                <a:ea typeface="Arial" pitchFamily="34" charset="-122"/>
-                <a:cs typeface="Arial" pitchFamily="34" charset="-120"/>
-              </a:rPr>
-              <a:t>Великий Ти! Вел‍‍икий Т‍‍и!</a:t>
-            </a:r>
-            <a:endParaRPr lang="en-US" sz="4400" dirty="0"/>
+              <a:rPr lang="en-US" sz="5100" b="1" dirty="0">
+                <a:solidFill>
+                  <a:srgbClr val="FFFFFF"/>
+                </a:solidFill>
+                <a:latin typeface="Arial" pitchFamily="34" charset="0"/>
+                <a:ea typeface="Arial" pitchFamily="34" charset="-122"/>
+                <a:cs typeface="Arial" pitchFamily="34" charset="-120"/>
+              </a:rPr>
+              <a:t>Коли беру я книгу Заповітів</a:t>
+            </a:r>
+            <a:endParaRPr lang="en-US" sz="5100" dirty="0"/>
+          </a:p>
+          <a:p>
+            <a:pPr algn="ctr" indent="0" marL="0">
+              <a:buNone/>
+            </a:pPr>
+            <a:r>
+              <a:rPr lang="en-US" sz="5100" b="1" dirty="0">
+                <a:solidFill>
+                  <a:srgbClr val="FFFFFF"/>
+                </a:solidFill>
+                <a:latin typeface="Arial" pitchFamily="34" charset="0"/>
+                <a:ea typeface="Arial" pitchFamily="34" charset="-122"/>
+                <a:cs typeface="Arial" pitchFamily="34" charset="-120"/>
+              </a:rPr>
+              <a:t>І в Ній читаю про Твої діла,</a:t>
+            </a:r>
+            <a:endParaRPr lang="en-US" sz="5100" dirty="0"/>
+          </a:p>
+          <a:p>
+            <a:pPr algn="ctr" indent="0" marL="0">
+              <a:buNone/>
+            </a:pPr>
+            <a:r>
+              <a:rPr lang="en-US" sz="5100" b="1" dirty="0">
+                <a:solidFill>
+                  <a:srgbClr val="FFFFFF"/>
+                </a:solidFill>
+                <a:latin typeface="Arial" pitchFamily="34" charset="0"/>
+                <a:ea typeface="Arial" pitchFamily="34" charset="-122"/>
+                <a:cs typeface="Arial" pitchFamily="34" charset="-120"/>
+              </a:rPr>
+              <a:t>Як полюбив Ти нас, людей на світі,</a:t>
+            </a:r>
+            <a:endParaRPr lang="en-US" sz="5100" dirty="0"/>
+          </a:p>
+          <a:p>
+            <a:pPr algn="ctr" indent="0" marL="0">
+              <a:buNone/>
+            </a:pPr>
+            <a:r>
+              <a:rPr lang="en-US" sz="5100" b="1" dirty="0">
+                <a:solidFill>
+                  <a:srgbClr val="FFFFFF"/>
+                </a:solidFill>
+                <a:latin typeface="Arial" pitchFamily="34" charset="0"/>
+                <a:ea typeface="Arial" pitchFamily="34" charset="-122"/>
+                <a:cs typeface="Arial" pitchFamily="34" charset="-120"/>
+              </a:rPr>
+              <a:t>І Свого Сина з неба нам послав;</a:t>
+            </a:r>
+            <a:endParaRPr lang="en-US" sz="5100" dirty="0"/>
           </a:p>
         </p:txBody>
       </p:sp>
@@ -2465,68 +2653,68 @@
               <a:buNone/>
             </a:pPr>
             <a:r>
-              <a:rPr lang="en-US" sz="5200" b="1" dirty="0">
-                <a:solidFill>
-                  <a:srgbClr val="FFFFFF"/>
-                </a:solidFill>
-                <a:latin typeface="Arial" pitchFamily="34" charset="0"/>
-                <a:ea typeface="Arial" pitchFamily="34" charset="-122"/>
-                <a:cs typeface="Arial" pitchFamily="34" charset="-120"/>
-              </a:rPr>
-              <a:t>Коли Господь мене Сам закликає,</a:t>
-            </a:r>
-            <a:endParaRPr lang="en-US" sz="5200" dirty="0"/>
-          </a:p>
-          <a:p>
-            <a:pPr algn="ctr" indent="0" marL="0">
-              <a:buNone/>
-            </a:pPr>
-            <a:r>
-              <a:rPr lang="en-US" sz="5200" b="1" dirty="0">
-                <a:solidFill>
-                  <a:srgbClr val="FFFFFF"/>
-                </a:solidFill>
-                <a:latin typeface="Arial" pitchFamily="34" charset="0"/>
-                <a:ea typeface="Arial" pitchFamily="34" charset="-122"/>
-                <a:cs typeface="Arial" pitchFamily="34" charset="-120"/>
-              </a:rPr>
-              <a:t>І світить промінь сяєва Його,</a:t>
-            </a:r>
-            <a:endParaRPr lang="en-US" sz="5200" dirty="0"/>
-          </a:p>
-          <a:p>
-            <a:pPr algn="ctr" indent="0" marL="0">
-              <a:buNone/>
-            </a:pPr>
-            <a:r>
-              <a:rPr lang="en-US" sz="5200" b="1" dirty="0">
-                <a:solidFill>
-                  <a:srgbClr val="FFFFFF"/>
-                </a:solidFill>
-                <a:latin typeface="Arial" pitchFamily="34" charset="0"/>
-                <a:ea typeface="Arial" pitchFamily="34" charset="-122"/>
-                <a:cs typeface="Arial" pitchFamily="34" charset="-120"/>
-              </a:rPr>
-              <a:t>Тоді мій дух в покорі замовкає,</a:t>
-            </a:r>
-            <a:endParaRPr lang="en-US" sz="5200" dirty="0"/>
-          </a:p>
-          <a:p>
-            <a:pPr algn="ctr" indent="0" marL="0">
-              <a:buNone/>
-            </a:pPr>
-            <a:r>
-              <a:rPr lang="en-US" sz="5200" b="1" dirty="0">
-                <a:solidFill>
-                  <a:srgbClr val="FFFFFF"/>
-                </a:solidFill>
-                <a:latin typeface="Arial" pitchFamily="34" charset="0"/>
-                <a:ea typeface="Arial" pitchFamily="34" charset="-122"/>
-                <a:cs typeface="Arial" pitchFamily="34" charset="-120"/>
-              </a:rPr>
-              <a:t>Признавши велич Господа свого!</a:t>
-            </a:r>
-            <a:endParaRPr lang="en-US" sz="5200" dirty="0"/>
+              <a:rPr lang="en-US" sz="5100" b="1" i="1" dirty="0">
+                <a:solidFill>
+                  <a:srgbClr val="FFFFFF"/>
+                </a:solidFill>
+                <a:latin typeface="Arial" pitchFamily="34" charset="0"/>
+                <a:ea typeface="Arial" pitchFamily="34" charset="-122"/>
+                <a:cs typeface="Arial" pitchFamily="34" charset="-120"/>
+              </a:rPr>
+              <a:t>Тоді, Госп‍‍одь, мій д‍‍ух співа То‍‍бі:</a:t>
+            </a:r>
+            <a:endParaRPr lang="en-US" sz="5100" dirty="0"/>
+          </a:p>
+          <a:p>
+            <a:pPr algn="ctr" indent="0" marL="0">
+              <a:buNone/>
+            </a:pPr>
+            <a:r>
+              <a:rPr lang="en-US" sz="5100" b="1" i="1" dirty="0">
+                <a:solidFill>
+                  <a:srgbClr val="FFFFFF"/>
+                </a:solidFill>
+                <a:latin typeface="Arial" pitchFamily="34" charset="0"/>
+                <a:ea typeface="Arial" pitchFamily="34" charset="-122"/>
+                <a:cs typeface="Arial" pitchFamily="34" charset="-120"/>
+              </a:rPr>
+              <a:t>Великий Т‍‍и! Великий Т‍‍и!</a:t>
+            </a:r>
+            <a:endParaRPr lang="en-US" sz="5100" dirty="0"/>
+          </a:p>
+          <a:p>
+            <a:pPr algn="ctr" indent="0" marL="0">
+              <a:buNone/>
+            </a:pPr>
+            <a:r>
+              <a:rPr lang="en-US" sz="5100" b="1" i="1" dirty="0">
+                <a:solidFill>
+                  <a:srgbClr val="FFFFFF"/>
+                </a:solidFill>
+                <a:latin typeface="Arial" pitchFamily="34" charset="0"/>
+                <a:ea typeface="Arial" pitchFamily="34" charset="-122"/>
+                <a:cs typeface="Arial" pitchFamily="34" charset="-120"/>
+              </a:rPr>
+              <a:t>Тоді, Госп‍‍одь, мій д‍‍ух співа То‍‍бі:</a:t>
+            </a:r>
+            <a:endParaRPr lang="en-US" sz="5100" dirty="0"/>
+          </a:p>
+          <a:p>
+            <a:pPr algn="ctr" indent="0" marL="0">
+              <a:buNone/>
+            </a:pPr>
+            <a:r>
+              <a:rPr lang="en-US" sz="5100" b="1" i="1" dirty="0">
+                <a:solidFill>
+                  <a:srgbClr val="FFFFFF"/>
+                </a:solidFill>
+                <a:latin typeface="Arial" pitchFamily="34" charset="0"/>
+                <a:ea typeface="Arial" pitchFamily="34" charset="-122"/>
+                <a:cs typeface="Arial" pitchFamily="34" charset="-120"/>
+              </a:rPr>
+              <a:t>Великий Ти! Вел‍‍икий Т‍‍и!</a:t>
+            </a:r>
+            <a:endParaRPr lang="en-US" sz="5100" dirty="0"/>
           </a:p>
         </p:txBody>
       </p:sp>
@@ -2587,107 +2775,68 @@
               <a:buNone/>
             </a:pPr>
             <a:r>
-              <a:rPr lang="en-US" sz="4400" b="1" i="1" dirty="0">
-                <a:solidFill>
-                  <a:srgbClr val="FFFFFF"/>
-                </a:solidFill>
-                <a:latin typeface="Arial" pitchFamily="34" charset="0"/>
-                <a:ea typeface="Arial" pitchFamily="34" charset="-122"/>
-                <a:cs typeface="Arial" pitchFamily="34" charset="-120"/>
-              </a:rPr>
-              <a:t>Тоді, Госп‍‍одь, мій д‍‍ух співа То‍‍бі:</a:t>
-            </a:r>
-            <a:endParaRPr lang="en-US" sz="4400" dirty="0"/>
-          </a:p>
-          <a:p>
-            <a:pPr algn="ctr" indent="0" marL="0">
-              <a:buNone/>
-            </a:pPr>
-            <a:r>
-              <a:rPr lang="en-US" sz="4400" b="1" i="1" dirty="0">
-                <a:solidFill>
-                  <a:srgbClr val="FFFFFF"/>
-                </a:solidFill>
-                <a:latin typeface="Arial" pitchFamily="34" charset="0"/>
-                <a:ea typeface="Arial" pitchFamily="34" charset="-122"/>
-                <a:cs typeface="Arial" pitchFamily="34" charset="-120"/>
-              </a:rPr>
-              <a:t>Великий Т‍‍и! Великий Т‍‍и!</a:t>
-            </a:r>
-            <a:endParaRPr lang="en-US" sz="4400" dirty="0"/>
-          </a:p>
-          <a:p>
-            <a:pPr algn="ctr" indent="0" marL="0">
-              <a:buNone/>
-            </a:pPr>
-            <a:r>
-              <a:rPr lang="en-US" sz="4400" b="1" i="1" dirty="0">
-                <a:solidFill>
-                  <a:srgbClr val="FFFFFF"/>
-                </a:solidFill>
-                <a:latin typeface="Arial" pitchFamily="34" charset="0"/>
-                <a:ea typeface="Arial" pitchFamily="34" charset="-122"/>
-                <a:cs typeface="Arial" pitchFamily="34" charset="-120"/>
-              </a:rPr>
-              <a:t>Тоді, Госп‍‍одь, мій д‍‍ух співа То‍‍бі:</a:t>
-            </a:r>
-            <a:endParaRPr lang="en-US" sz="4400" dirty="0"/>
-          </a:p>
-          <a:p>
-            <a:pPr algn="ctr" indent="0" marL="0">
-              <a:buNone/>
-            </a:pPr>
-            <a:r>
-              <a:rPr lang="en-US" sz="4400" b="1" i="1" dirty="0">
-                <a:solidFill>
-                  <a:srgbClr val="FFFFFF"/>
-                </a:solidFill>
-                <a:latin typeface="Arial" pitchFamily="34" charset="0"/>
-                <a:ea typeface="Arial" pitchFamily="34" charset="-122"/>
-                <a:cs typeface="Arial" pitchFamily="34" charset="-120"/>
-              </a:rPr>
-              <a:t>Великий Ти! Вел‍‍икий Т‍‍и!</a:t>
-            </a:r>
-            <a:endParaRPr lang="en-US" sz="4400" dirty="0"/>
-          </a:p>
-        </p:txBody>
-      </p:sp>
-      <p:sp>
-        <p:nvSpPr>
-          <p:cNvPr id="3" name="Text 1"/>
-          <p:cNvSpPr txBox="1"/>
-          <p:nvPr/>
-        </p:nvSpPr>
-        <p:spPr>
-          <a:xfrm>
-            <a:off x="9235440" y="6126480"/>
-            <a:ext cx="2743200" cy="548640"/>
-          </a:xfrm>
-          <a:prstGeom prst="rect">
-            <a:avLst/>
-          </a:prstGeom>
-          <a:noFill/>
-          <a:ln/>
-        </p:spPr>
-        <p:txBody>
-          <a:bodyPr wrap="square" lIns="0" tIns="0" rIns="0" bIns="0" rtlCol="0" anchor="ctr"/>
-          <a:lstStyle/>
-          <a:p>
-            <a:pPr algn="r" indent="0" marL="0">
-              <a:buNone/>
-            </a:pPr>
-            <a:r>
-              <a:rPr lang="en-US" sz="2400" dirty="0">
-                <a:solidFill>
-                  <a:srgbClr val="8A8A8A"/>
-                </a:solidFill>
-                <a:latin typeface="Arial" pitchFamily="34" charset="0"/>
-                <a:ea typeface="Arial" pitchFamily="34" charset="-122"/>
-                <a:cs typeface="Arial" pitchFamily="34" charset="-120"/>
-              </a:rPr>
-              <a:t>● ○</a:t>
-            </a:r>
-            <a:endParaRPr lang="en-US" sz="2400" dirty="0"/>
+              <a:rPr lang="en-US" sz="5100" b="1" dirty="0">
+                <a:solidFill>
+                  <a:srgbClr val="FFFFFF"/>
+                </a:solidFill>
+                <a:latin typeface="Arial" pitchFamily="34" charset="0"/>
+                <a:ea typeface="Arial" pitchFamily="34" charset="-122"/>
+                <a:cs typeface="Arial" pitchFamily="34" charset="-120"/>
+              </a:rPr>
+              <a:t>Коли Господь мене Сам закликає,</a:t>
+            </a:r>
+            <a:endParaRPr lang="en-US" sz="5100" dirty="0"/>
+          </a:p>
+          <a:p>
+            <a:pPr algn="ctr" indent="0" marL="0">
+              <a:buNone/>
+            </a:pPr>
+            <a:r>
+              <a:rPr lang="en-US" sz="5100" b="1" dirty="0">
+                <a:solidFill>
+                  <a:srgbClr val="FFFFFF"/>
+                </a:solidFill>
+                <a:latin typeface="Arial" pitchFamily="34" charset="0"/>
+                <a:ea typeface="Arial" pitchFamily="34" charset="-122"/>
+                <a:cs typeface="Arial" pitchFamily="34" charset="-120"/>
+              </a:rPr>
+              <a:t>І світить промінь сяєва Його,</a:t>
+            </a:r>
+            <a:endParaRPr lang="en-US" sz="5100" dirty="0"/>
+          </a:p>
+          <a:p>
+            <a:pPr algn="ctr" indent="0" marL="0">
+              <a:buNone/>
+            </a:pPr>
+            <a:r>
+              <a:rPr lang="en-US" sz="5100" b="1" dirty="0">
+                <a:solidFill>
+                  <a:srgbClr val="FFFFFF"/>
+                </a:solidFill>
+                <a:latin typeface="Arial" pitchFamily="34" charset="0"/>
+                <a:ea typeface="Arial" pitchFamily="34" charset="-122"/>
+                <a:cs typeface="Arial" pitchFamily="34" charset="-120"/>
+              </a:rPr>
+              <a:t>Тоді мій дух в покорі замовкає,</a:t>
+            </a:r>
+            <a:endParaRPr lang="en-US" sz="5100" dirty="0"/>
+          </a:p>
+          <a:p>
+            <a:pPr algn="ctr" indent="0" marL="0">
+              <a:buNone/>
+            </a:pPr>
+            <a:r>
+              <a:rPr lang="en-US" sz="5100" b="1" dirty="0">
+                <a:solidFill>
+                  <a:srgbClr val="FFFFFF"/>
+                </a:solidFill>
+                <a:latin typeface="Arial" pitchFamily="34" charset="0"/>
+                <a:ea typeface="Arial" pitchFamily="34" charset="-122"/>
+                <a:cs typeface="Arial" pitchFamily="34" charset="-120"/>
+              </a:rPr>
+              <a:t>Признавши велич Господа свого!</a:t>
+            </a:r>
+            <a:endParaRPr lang="en-US" sz="5100" dirty="0"/>
           </a:p>
         </p:txBody>
       </p:sp>
@@ -2748,7 +2897,58 @@
               <a:buNone/>
             </a:pPr>
             <a:r>
-              <a:rPr lang="en-US" sz="6000" b="1" i="1" dirty="0">
+              <a:rPr lang="en-US" sz="5100" b="1" i="1" dirty="0">
+                <a:solidFill>
+                  <a:srgbClr val="FFFFFF"/>
+                </a:solidFill>
+                <a:latin typeface="Arial" pitchFamily="34" charset="0"/>
+                <a:ea typeface="Arial" pitchFamily="34" charset="-122"/>
+                <a:cs typeface="Arial" pitchFamily="34" charset="-120"/>
+              </a:rPr>
+              <a:t>Тоді, Госп‍‍одь, мій д‍‍ух співа То‍‍бі:</a:t>
+            </a:r>
+            <a:endParaRPr lang="en-US" sz="5100" dirty="0"/>
+          </a:p>
+          <a:p>
+            <a:pPr algn="ctr" indent="0" marL="0">
+              <a:buNone/>
+            </a:pPr>
+            <a:r>
+              <a:rPr lang="en-US" sz="5100" b="1" i="1" dirty="0">
+                <a:solidFill>
+                  <a:srgbClr val="FFFFFF"/>
+                </a:solidFill>
+                <a:latin typeface="Arial" pitchFamily="34" charset="0"/>
+                <a:ea typeface="Arial" pitchFamily="34" charset="-122"/>
+                <a:cs typeface="Arial" pitchFamily="34" charset="-120"/>
+              </a:rPr>
+              <a:t>Великий Т‍‍и! Великий Т‍‍и!</a:t>
+            </a:r>
+            <a:endParaRPr lang="en-US" sz="5100" dirty="0"/>
+          </a:p>
+          <a:p>
+            <a:pPr algn="ctr" indent="0" marL="0">
+              <a:buNone/>
+            </a:pPr>
+            <a:r>
+              <a:rPr lang="en-US" sz="5100" b="1" i="1" dirty="0">
+                <a:solidFill>
+                  <a:srgbClr val="FFFFFF"/>
+                </a:solidFill>
+                <a:latin typeface="Arial" pitchFamily="34" charset="0"/>
+                <a:ea typeface="Arial" pitchFamily="34" charset="-122"/>
+                <a:cs typeface="Arial" pitchFamily="34" charset="-120"/>
+              </a:rPr>
+              <a:t>Тоді, Госп‍‍одь, мій д‍‍ух співа То‍‍бі:</a:t>
+            </a:r>
+            <a:endParaRPr lang="en-US" sz="5100" dirty="0"/>
+          </a:p>
+          <a:p>
+            <a:pPr algn="ctr" indent="0" marL="0">
+              <a:buNone/>
+            </a:pPr>
+            <a:r>
+              <a:rPr lang="en-US" sz="5100" b="1" i="1" dirty="0">
                 <a:solidFill>
                   <a:srgbClr val="FFFFFF"/>
                 </a:solidFill>
@@ -2758,30 +2958,7 @@
               </a:rPr>
               <a:t>Великий Ти! Вел‍‍икий Т‍‍и!</a:t>
             </a:r>
-            <a:endParaRPr lang="en-US" sz="6000" dirty="0"/>
-          </a:p>
-          <a:p>
-            <a:pPr algn="ctr" indent="0" marL="0">
-              <a:buNone/>
-            </a:pPr>
-            <a:endParaRPr lang="en-US" sz="6000" dirty="0"/>
-          </a:p>
-          <a:p>
-            <a:pPr algn="ctr" indent="0" marL="0">
-              <a:buNone/>
-            </a:pPr>
-            <a:r>
-              <a:rPr lang="en-US" sz="6000" b="1" i="1" dirty="0">
-                <a:solidFill>
-                  <a:srgbClr val="FFFFFF"/>
-                </a:solidFill>
-                <a:latin typeface="Arial" pitchFamily="34" charset="0"/>
-                <a:ea typeface="Arial" pitchFamily="34" charset="-122"/>
-                <a:cs typeface="Arial" pitchFamily="34" charset="-120"/>
-              </a:rPr>
-              <a:t>***</a:t>
-            </a:r>
-            <a:endParaRPr lang="en-US" sz="6000" dirty="0"/>
+            <a:endParaRPr lang="en-US" sz="5100" dirty="0"/>
           </a:p>
         </p:txBody>
       </p:sp>
@@ -2818,7 +2995,7 @@
                 <a:ea typeface="Arial" pitchFamily="34" charset="-122"/>
                 <a:cs typeface="Arial" pitchFamily="34" charset="-120"/>
               </a:rPr>
-              <a:t>○ ●</a:t>
+              <a:t>● ○</a:t>
             </a:r>
             <a:endParaRPr lang="en-US" sz="2400" dirty="0"/>
           </a:p>

</xml_diff>